<commit_message>
Updates to presenter notes
</commit_message>
<xml_diff>
--- a/lectures/Session01-CourseLaunch.pptx
+++ b/lectures/Session01-CourseLaunch.pptx
@@ -523,7 +523,7 @@
           <a:p>
             <a:r>
               <a:rPr lang="en-US" dirty="0"/>
-              <a:t>Welcome. Keep intros light. Set the promise: by finals you'll have founded and launched a real project others want to help build.</a:t>
+              <a:t>Open the room and set the tone. Welcome them, read the energy, keep personal intros light (name, major, one thing they've built) but don't let intros eat the clock — there's a lot to cover. Land the promise plainly: by finals, each of them will have founded and launched a real open-source project that others actually want to help build. Signal early that this course works differently from the assignment-driven courses they're used to. ~2-3 min.</a:t>
             </a:r>
             <a:endParaRPr lang="en-US" dirty="0"/>
           </a:p>
@@ -611,7 +611,7 @@
           <a:p>
             <a:r>
               <a:rPr lang="en-US" dirty="0"/>
-              <a:t>Show ~2 each. The clone connects to the design prereq — frame gently, let it surface organically.</a:t>
+              <a:t>Show about two examples per side; don't read all the text. Strong ideas have real, reachable users, richness, and a clear one-semester MVP; weak ones have no unmet need (the generic to-do app) or a need already met (a clone). Handle the clone point gently — cloning is great for LEARNING, which is exactly why the design prereq builds them, just not for FOUNDING. Let that distinction surface in discussion rather than lecturing it. ~2-3 min.</a:t>
             </a:r>
             <a:endParaRPr lang="en-US" dirty="0"/>
           </a:p>
@@ -699,7 +699,7 @@
           <a:p>
             <a:r>
               <a:rPr lang="en-US" dirty="0"/>
-              <a:t>Emphasize real-need and richness. Note solo/smaller scope allowed. Preview Value vs. Do-ability for Week 3.</a:t>
+              <a:t>This is the shared yardstick for the Idea Briefs. Walk the list but linger on the two starred criteria — a real need for a real, reachable userbase, and richness/breadth — because those are the two students most often miss. Note that solo projects and smaller scope are welcome. Preview that Value vs. Do-ability (Week 3) is how they'll weigh these formally. ~2 min.</a:t>
             </a:r>
             <a:endParaRPr lang="en-US" dirty="0"/>
           </a:p>
@@ -787,7 +787,7 @@
           <a:p>
             <a:r>
               <a:rPr lang="en-US" dirty="0"/>
-              <a:t>Model the move live: take a too-small or too-big idea and reshape it against the criteria.</a:t>
+              <a:t>Model the convergence move live rather than just showing it. Take a too-small idea ("a to-do app") or a too-big one ("a new social network") and reshape it out loud against the criteria until it passes — same domain, now with real users and real richness. Tell them this is exactly the move they'll make for real in the Week-3 workshop. If time allows, invite a student to reshape one of their own. ~2 min.</a:t>
             </a:r>
             <a:endParaRPr lang="en-US" dirty="0"/>
           </a:p>
@@ -875,7 +875,7 @@
           <a:p>
             <a:r>
               <a:rPr lang="en-US" dirty="0"/>
-              <a:t>Real users are the ideal; documented persona/proxy is an accepted substitute this iteration (Week 2).</a:t>
+              <a:t>Four things a founder owns: the user need, the decisions, the pathways, and the norms. Land the navy banner hard — the central job of the course is to understand a real user's need well enough to speak for it. Set expectations honestly: real users are the ideal we push toward, and a documented persona/proxy is an accepted substitute this iteration (they'll build one in Week 2). ~2 min.</a:t>
             </a:r>
             <a:endParaRPr lang="en-US" dirty="0"/>
           </a:p>
@@ -963,7 +963,7 @@
           <a:p>
             <a:r>
               <a:rPr lang="en-US" dirty="0"/>
-              <a:t>Pose each as 'what would you do?' for ~30s before revealing the call. Setup → the tension → the lesson. Reserve: serving the user, not yourself.</a:t>
+              <a:t>The interactive beat — three vignettes. For each, pose "what would you do?" and give ~30 seconds for reactions before you reveal the call. Structure each as setup, then the tension, then the lesson: saying no to a feature (a founder decides which tickets exist), the boring stack (own it, don't show off), the first outside PR (how you treat a stranger's PR IS the culture). The unifying lesson: serve the user, not your ego. ~4-5 min.</a:t>
             </a:r>
             <a:endParaRPr lang="en-US" dirty="0"/>
           </a:p>
@@ -1051,7 +1051,7 @@
           <a:p>
             <a:r>
               <a:rPr lang="en-US" dirty="0"/>
-              <a:t>Flesh out the rhythm: Monday teaches, Wednesday does. The draft→review→revise→build→reflect loop is the engine of the course.</a:t>
+              <a:t>Explain the studio rhythm concretely: Monday teaches (short lecture, worked examples, critique), Wednesday does (workshop, lab, peer review, or demo — often released early). The repeating engine is draft, review, revise, build, reflect — call that the loop that drives the whole course. Reassure them Wednesdays won't always use the full 75 minutes. ~2 min.</a:t>
             </a:r>
             <a:endParaRPr lang="en-US" dirty="0"/>
           </a:p>
@@ -1139,7 +1139,7 @@
           <a:p>
             <a:r>
               <a:rPr lang="en-US" dirty="0"/>
-              <a:t>They've done no reading — this is their first exposure. Keep it to the four stage names + one line each. Sets up the CPS→phases slide.</a:t>
+              <a:t>They've done no reading yet — this is their first exposure to Creative Problem Solving, so keep it light. Give the premise (creativity is a practicable skill; how you approach a problem changes your odds of a breakthrough) and the four stage names with one line each: Clarification, Ideation, Development, Implementation. Don't drill it — the Session 2 reading and workshop go deep. This just sets up the CPS-to-phases mapping. ~2 min.</a:t>
             </a:r>
             <a:endParaRPr lang="en-US" dirty="0"/>
           </a:p>
@@ -1227,7 +1227,7 @@
           <a:p>
             <a:r>
               <a:rPr lang="en-US" dirty="0"/>
-              <a:t>This is the emphasis. The research hook motivates deferring judgment. Full CPS + egg-drop exercise come Sep 9.</a:t>
+              <a:t>This is the heart of what we emphasize, so give it a moment. Every stage uses both modes: generate widely (defer judgment, prefer quantity, welcome wild ideas, build on others') before you narrow (judge against goals and constraints, decide with evidence, keep the novelty alive). Use the research hook in the navy banner to motivate deferring judgment — groups that pile up ideas before judging outperform those that judge as they go, which is why the Idea Briefs ask for three, not one. The full CPS run and the egg-drop exercise come Sep 9. ~2-3 min.</a:t>
             </a:r>
             <a:endParaRPr lang="en-US" dirty="0"/>
           </a:p>
@@ -1315,7 +1315,7 @@
           <a:p>
             <a:r>
               <a:rPr lang="en-US" dirty="0"/>
-              <a:t>Now the four stages are familiar, this mapping lands. The Week-5 pitch is the hinge.</a:t>
+              <a:t>Now that the four stages are familiar, this mapping lands: the four CPS stages map onto the five course phases across the term. The Week-5 pitch is the hinge — where individual work becomes team work. Reassure them explicitly that a solo path is welcome and no one's idea gets killed out from under them. ~2 min.</a:t>
             </a:r>
             <a:endParaRPr lang="en-US" dirty="0"/>
           </a:p>
@@ -1403,7 +1403,7 @@
           <a:p>
             <a:r>
               <a:rPr lang="en-US" dirty="0"/>
-              <a:t>Fill the placeholder card with your actual syllabus items before class.</a:t>
+              <a:t>Keep this tight — do NOT read the syllabus aloud; point them to the LMS. Say the workload plainly: about 10 hours a week (roughly 2.5 in class, 7.5 outside). Stress that process and founding artifacts carry real weight — strong code alone won't compensate. On AI: it's a tool, not the topic — fine for brainstorming, learning, and drafting, but they must understand and be able to defend everything they submit. Fill the placeholder card with your actual syllabus items before class. ~2-3 min.</a:t>
             </a:r>
             <a:endParaRPr lang="en-US" dirty="0"/>
           </a:p>
@@ -1491,7 +1491,7 @@
           <a:p>
             <a:r>
               <a:rPr lang="en-US" dirty="0"/>
-              <a:t>Deliver the hook. Name 2-3 examples aloud, then land the turn: '…and this semester, that's you — maybe with a teammate.'</a:t>
+              <a:t>This is the emotional open — deliver it, don't read it. Say the line, then name two or three open-source projects you personally love as living proof that big things start small. Then land the turn slowly: "…and this semester, that's you — maybe with a teammate," and let it sit a beat before advancing. The goal is to make founding feel attainable rather than mythical. ~2 min.</a:t>
             </a:r>
             <a:endParaRPr lang="en-US" dirty="0"/>
           </a:p>
@@ -1579,7 +1579,7 @@
           <a:p>
             <a:r>
               <a:rPr lang="en-US" dirty="0"/>
-              <a:t>Kick off a short discussion of the idea journal — what it is and why it matters. Refer them to the full Idea-Journal handout for prompts and how to use it. The in-class activity that starts the journal is on the next slide.</a:t>
+              <a:t>Their first move. Point them to the CP1 assignment: three genuinely DIFFERENT one-page problem concepts (not three flavors of one app), plus a short reflection on what makes a project worth building to last, due Wed Sep 23. Then introduce the idea journal — a low-effort running log of problems (needs, not solutions) kept over three weeks. Emphasize that good briefs come from weeks of noticing, not a night-before scramble. The next slide starts the journal in class. ~3 min.</a:t>
             </a:r>
             <a:endParaRPr lang="en-US" dirty="0"/>
           </a:p>
@@ -1667,7 +1667,7 @@
           <a:p>
             <a:r>
               <a:rPr lang="en-US" dirty="0"/>
-              <a:t>Solo first (protects individual generation). 3 minutes silent. Then collect a few aloud with pure acceptance — no evaluating — to model deferring judgment. Don't collect or grade; the list becomes journal entry #1. A taste of the Sep 9 divergent workshop.</a:t>
+              <a:t>Run this for real. Solo and silent first for three minutes — this protects individual generation before any group influence. The prompt: list as many problems (broken, annoying, tedious, slow, missing) as you can, aim for 8+, and don't judge or solve. Then collect a few aloud with PURE acceptance — no evaluating — to model deferring judgment. Don't collect or grade; the list becomes journal entry #1 and a taste of the Sep 9 divergent workshop. ~5 min.</a:t>
             </a:r>
             <a:endParaRPr lang="en-US" dirty="0"/>
           </a:p>
@@ -1755,7 +1755,7 @@
           <a:p>
             <a:r>
               <a:rPr lang="en-US" dirty="0"/>
-              <a:t>Recap the one big idea. Point them to the two handouts (CP1 Idea Briefs + Idea Journal) and the two readings (CPS handbook excerpt + Hales, 'Channeling Your Creativity'). Flag the shift: from here on, sessions expect pre-reading.</a:t>
+              <a:t>Recap the one big idea: founders find and prove problems, and we start by exploring widely. Point them to the two handouts (CP1 Idea Briefs and the Idea Journal guide) and the two readings for Sep 9 (the assigned CPS handbook excerpt and Elder Hales, "Channeling Your Creativity"). Flag the shift explicitly — from here on, sessions expect pre-reading. Send them off to keep feeding the journal and bring raw problems to the divergent workshop. ~1-2 min.</a:t>
             </a:r>
             <a:endParaRPr lang="en-US" dirty="0"/>
           </a:p>
@@ -1843,7 +1843,7 @@
           <a:p>
             <a:r>
               <a:rPr lang="en-US" dirty="0"/>
-              <a:t>Only four, so you can dwell on each. Note each attracted collaborators fast — that's the arc this course puts them on.</a:t>
+              <a:t>Only four examples, on purpose, so you can dwell on each — resist rushing. For each, contrast the humble "itch" with the "now" to show the arc from one person's decision to world-scale impact. The through-line to stress: every one of them attracted collaborators fast, which is exactly the arc this course puts students on. End on MySQL — two founders with a shared itch is the shape most of their teams will take. ~3-4 min.</a:t>
             </a:r>
             <a:endParaRPr lang="en-US" dirty="0"/>
           </a:p>
@@ -1931,7 +1931,7 @@
           <a:p>
             <a:r>
               <a:rPr lang="en-US" dirty="0"/>
-              <a:t>The core reframe. Contributor/founder contrast on the next slide.</a:t>
+              <a:t>The core reframe of the whole course, so slow down. Most of their courses hand them the problem; here they go find a real one, prove it's worth solving, and lay a foundation others can build on. The navy card is the punchline: they are the founder/maintainer, not a contributor to someone else's vision. Tee up the contributor-vs-founder table on the next slide, which makes this concrete. ~2-3 min.</a:t>
             </a:r>
             <a:endParaRPr lang="en-US" dirty="0"/>
           </a:p>
@@ -2019,7 +2019,7 @@
           <a:p>
             <a:r>
               <a:rPr lang="en-US" dirty="0"/>
-              <a:t>The whole right column IS the course.</a:t>
+              <a:t>Walk the table row by row and read the founder (right) column aloud — that entire column IS the course. Be explicit that you're not disparaging the contributor role: it's valuable and most of them have done it; founding just demands an extra set of muscles — finding the problem, deciding, writing the norms, building the on-ramps. Pause on the last row: success here isn't a merged PR, it's a launched project people want to help build. ~3 min.</a:t>
             </a:r>
             <a:endParaRPr lang="en-US" dirty="0"/>
           </a:p>
@@ -2107,7 +2107,7 @@
           <a:p>
             <a:r>
               <a:rPr lang="en-US" dirty="0"/>
-              <a:t>The destination every later assignment points at.</a:t>
+              <a:t>Show the destination so every later assignment has a visible target: a working MVP, an open-source-ready repo, a launch &amp; onboarding package, and the public demo. Land the navy banner hard — what distinguishes a passing student is not strong code alone but a founded, defensible, contributor-ready project. This is where you gently preempt the "I'll just build something cool" instinct. ~2 min.</a:t>
             </a:r>
             <a:endParaRPr lang="en-US" dirty="0"/>
           </a:p>
@@ -2195,7 +2195,7 @@
           <a:p>
             <a:r>
               <a:rPr lang="en-US" dirty="0"/>
-              <a:t>Orient them: discovery is individual (Wks 1-5), teams form at the Week-5 pitch, then design/build/launch. It all lands on one demo day.</a:t>
+              <a:t>Orient them in time. Discovery is individual for the first five weeks; teams form at the Week-5 pitch; then design, build, and launch, all landing on one public demo day. Stress that every assignment is a deliberate step toward that demo, not busywork. Reassure anyone anxious about teams — that's weeks away and they'll have real data by then. ~2 min.</a:t>
             </a:r>
             <a:endParaRPr lang="en-US" dirty="0"/>
           </a:p>
@@ -2283,7 +2283,7 @@
           <a:p>
             <a:r>
               <a:rPr lang="en-US" dirty="0"/>
-              <a:t>Segment 3 showed the artifact; this shows the capabilities. Spotlight technical communication as the through-line — the outcome students most underrate.</a:t>
+              <a:t>Distinguish these from today's session objectives — these are what they'll be able to DO by end of term. Walk the five capabilities briefly, then spotlight the navy card: technical communication is the through-line — proposals, pitches, design docs, issues, PRs, reviews, launch docs. Say plainly they'll do more writing and reviewing than fresh coding, and that we treat it as core engineering work, not a soft skill. This is the outcome students most underrate. ~2-3 min.</a:t>
             </a:r>
             <a:endParaRPr lang="en-US" dirty="0"/>
           </a:p>
@@ -2371,7 +2371,7 @@
           <a:p>
             <a:r>
               <a:rPr lang="en-US" dirty="0"/>
-              <a:t>Keep brief and authentic. Gospel / eternal-perspective framing comes from live delivery.</a:t>
+              <a:t>Keep this brief and authentic — the gospel and eternal-perspective framing lands best from you, live, not from the slide. The four aims map cleanly: serve a real need, teach yourself, act with integrity, do work of consequence. Touch the five C's lightly rather than laboring them. Don't over-spiritualize; let the connection feel natural. ~1-2 min.</a:t>
             </a:r>
             <a:endParaRPr lang="en-US" dirty="0"/>
           </a:p>

</xml_diff>

<commit_message>
Add Session 6 and related changes.
</commit_message>
<xml_diff>
--- a/lectures/Session01-CourseLaunch.pptx
+++ b/lectures/Session01-CourseLaunch.pptx
@@ -699,7 +699,7 @@
           <a:p>
             <a:r>
               <a:rPr lang="en-US" dirty="0"/>
-              <a:t>This is the shared yardstick for the Idea Briefs. Walk the list but linger on the two starred criteria — a real need for a real, reachable userbase, and richness/breadth — because those are the two students most often miss. Note that solo projects and smaller scope are welcome. Preview that Value vs. Do-ability (Week 3) is how they'll weigh these formally. ~2 min.</a:t>
+              <a:t>This is the shared yardstick for the Idea Briefs. Walk the list but linger on the two starred criteria — a real need for a real, reachable userbase, and richness/breadth — because those are the two students most often miss. Note that solo projects and smaller scope are welcome. Seed the throughline (amber bar): scoring ideas against explicit criteria is a portable skill they'll use all semester — on their own ideas, on peers' pitches, on design docs and demos — and beyond the class; these seven are just what "good" means here. Preview that Value vs. Do-ability (Week 3) is how they'll weigh these formally. ~2 min.</a:t>
             </a:r>
             <a:endParaRPr lang="en-US" dirty="0"/>
           </a:p>
@@ -3945,7 +3945,7 @@
         </p:nvSpPr>
         <p:spPr>
           <a:xfrm>
-            <a:off x="640080" y="2432304"/>
+            <a:off x="640080" y="2359152"/>
             <a:ext cx="420624" cy="420624"/>
           </a:xfrm>
           <a:prstGeom prst="ellipse">
@@ -3973,7 +3973,7 @@
         </p:blipFill>
         <p:spPr>
           <a:xfrm>
-            <a:off x="753648" y="2545872"/>
+            <a:off x="753648" y="2472720"/>
             <a:ext cx="193487" cy="193487"/>
           </a:xfrm>
           <a:prstGeom prst="rect">
@@ -3989,7 +3989,7 @@
         </p:nvSpPr>
         <p:spPr>
           <a:xfrm>
-            <a:off x="1280160" y="2432304"/>
+            <a:off x="1280160" y="2359152"/>
             <a:ext cx="7315200" cy="420624"/>
           </a:xfrm>
           <a:prstGeom prst="rect">
@@ -4028,7 +4028,7 @@
         </p:nvSpPr>
         <p:spPr>
           <a:xfrm>
-            <a:off x="640080" y="3035808"/>
+            <a:off x="640080" y="2889504"/>
             <a:ext cx="420624" cy="420624"/>
           </a:xfrm>
           <a:prstGeom prst="ellipse">
@@ -4056,7 +4056,7 @@
         </p:blipFill>
         <p:spPr>
           <a:xfrm>
-            <a:off x="753648" y="3149376"/>
+            <a:off x="753648" y="3003072"/>
             <a:ext cx="193487" cy="193487"/>
           </a:xfrm>
           <a:prstGeom prst="rect">
@@ -4072,7 +4072,7 @@
         </p:nvSpPr>
         <p:spPr>
           <a:xfrm>
-            <a:off x="1280160" y="3035808"/>
+            <a:off x="1280160" y="2889504"/>
             <a:ext cx="7315200" cy="420624"/>
           </a:xfrm>
           <a:prstGeom prst="rect">
@@ -4111,7 +4111,7 @@
         </p:nvSpPr>
         <p:spPr>
           <a:xfrm>
-            <a:off x="640080" y="3639312"/>
+            <a:off x="640080" y="3419856"/>
             <a:ext cx="420624" cy="420624"/>
           </a:xfrm>
           <a:prstGeom prst="ellipse">
@@ -4139,7 +4139,7 @@
         </p:blipFill>
         <p:spPr>
           <a:xfrm>
-            <a:off x="753648" y="3752880"/>
+            <a:off x="753648" y="3533424"/>
             <a:ext cx="193487" cy="193487"/>
           </a:xfrm>
           <a:prstGeom prst="rect">
@@ -4155,7 +4155,7 @@
         </p:nvSpPr>
         <p:spPr>
           <a:xfrm>
-            <a:off x="1280160" y="3639312"/>
+            <a:off x="1280160" y="3419856"/>
             <a:ext cx="7315200" cy="420624"/>
           </a:xfrm>
           <a:prstGeom prst="rect">
@@ -4194,7 +4194,7 @@
         </p:nvSpPr>
         <p:spPr>
           <a:xfrm>
-            <a:off x="640080" y="4242816"/>
+            <a:off x="640080" y="3950208"/>
             <a:ext cx="420624" cy="420624"/>
           </a:xfrm>
           <a:prstGeom prst="ellipse">
@@ -4222,7 +4222,7 @@
         </p:blipFill>
         <p:spPr>
           <a:xfrm>
-            <a:off x="753648" y="4356384"/>
+            <a:off x="753648" y="4063776"/>
             <a:ext cx="193487" cy="193487"/>
           </a:xfrm>
           <a:prstGeom prst="rect">
@@ -4238,7 +4238,7 @@
         </p:nvSpPr>
         <p:spPr>
           <a:xfrm>
-            <a:off x="1280160" y="4242816"/>
+            <a:off x="1280160" y="3950208"/>
             <a:ext cx="7315200" cy="420624"/>
           </a:xfrm>
           <a:prstGeom prst="rect">
@@ -4277,7 +4277,7 @@
         </p:nvSpPr>
         <p:spPr>
           <a:xfrm>
-            <a:off x="640080" y="4846320"/>
+            <a:off x="640080" y="4480560"/>
             <a:ext cx="420624" cy="420624"/>
           </a:xfrm>
           <a:prstGeom prst="ellipse">
@@ -4305,7 +4305,7 @@
         </p:blipFill>
         <p:spPr>
           <a:xfrm>
-            <a:off x="753648" y="4959888"/>
+            <a:off x="753648" y="4594128"/>
             <a:ext cx="193487" cy="193487"/>
           </a:xfrm>
           <a:prstGeom prst="rect">
@@ -4321,7 +4321,7 @@
         </p:nvSpPr>
         <p:spPr>
           <a:xfrm>
-            <a:off x="1280160" y="4846320"/>
+            <a:off x="1280160" y="4480560"/>
             <a:ext cx="7315200" cy="420624"/>
           </a:xfrm>
           <a:prstGeom prst="rect">
@@ -4360,7 +4360,7 @@
         </p:nvSpPr>
         <p:spPr>
           <a:xfrm>
-            <a:off x="640080" y="5449824"/>
+            <a:off x="640080" y="5010912"/>
             <a:ext cx="420624" cy="420624"/>
           </a:xfrm>
           <a:prstGeom prst="ellipse">
@@ -4388,7 +4388,7 @@
         </p:blipFill>
         <p:spPr>
           <a:xfrm>
-            <a:off x="753648" y="5563392"/>
+            <a:off x="753648" y="5124480"/>
             <a:ext cx="193487" cy="193487"/>
           </a:xfrm>
           <a:prstGeom prst="rect">
@@ -4404,7 +4404,7 @@
         </p:nvSpPr>
         <p:spPr>
           <a:xfrm>
-            <a:off x="1280160" y="5449824"/>
+            <a:off x="1280160" y="5010912"/>
             <a:ext cx="7315200" cy="420624"/>
           </a:xfrm>
           <a:prstGeom prst="rect">
@@ -4588,7 +4588,95 @@
       </p:sp>
       <p:sp>
         <p:nvSpPr>
-          <p:cNvPr id="31" name="Text 21"/>
+          <p:cNvPr id="31" name="Shape 21"/>
+          <p:cNvSpPr/>
+          <p:nvPr/>
+        </p:nvSpPr>
+        <p:spPr>
+          <a:xfrm>
+            <a:off x="548640" y="5577840"/>
+            <a:ext cx="11064240" cy="585216"/>
+          </a:xfrm>
+          <a:prstGeom prst="roundRect">
+            <a:avLst>
+              <a:gd name="adj" fmla="val 14063"/>
+            </a:avLst>
+          </a:prstGeom>
+          <a:solidFill>
+            <a:srgbClr val="E8A33D"/>
+          </a:solidFill>
+          <a:ln/>
+          <a:effectLst>
+            <a:outerShdw sx="100000" sy="100000" kx="0" ky="0" algn="bl" rotWithShape="0" blurRad="88900" dist="38100" dir="5400000">
+              <a:srgbClr val="000000">
+                <a:alpha val="13000"/>
+              </a:srgbClr>
+            </a:outerShdw>
+          </a:effectLst>
+        </p:spPr>
+      </p:sp>
+      <p:sp>
+        <p:nvSpPr>
+          <p:cNvPr id="32" name="Text 22"/>
+          <p:cNvSpPr/>
+          <p:nvPr/>
+        </p:nvSpPr>
+        <p:spPr>
+          <a:xfrm>
+            <a:off x="822960" y="5577840"/>
+            <a:ext cx="10515600" cy="585216"/>
+          </a:xfrm>
+          <a:prstGeom prst="rect">
+            <a:avLst/>
+          </a:prstGeom>
+          <a:noFill/>
+          <a:ln/>
+        </p:spPr>
+        <p:txBody>
+          <a:bodyPr wrap="square" lIns="0" tIns="0" rIns="0" bIns="0" rtlCol="0" anchor="ctr"/>
+          <a:lstStyle/>
+          <a:p>
+            <a:pPr algn="ctr" indent="0" marL="0">
+              <a:lnSpc>
+                <a:spcPct val="102000"/>
+              </a:lnSpc>
+              <a:buNone/>
+            </a:pPr>
+            <a:r>
+              <a:rPr lang="en-US" sz="1350" b="1" dirty="0">
+                <a:solidFill>
+                  <a:srgbClr val="14233A"/>
+                </a:solidFill>
+                <a:latin typeface="Calibri" pitchFamily="34" charset="0"/>
+                <a:ea typeface="Calibri" pitchFamily="34" charset="-122"/>
+                <a:cs typeface="Calibri" pitchFamily="34" charset="-120"/>
+              </a:rPr>
+              <a:t>A skill, not just a checklist:  </a:t>
+            </a:r>
+            <a:pPr algn="ctr" indent="0" marL="0">
+              <a:lnSpc>
+                <a:spcPct val="102000"/>
+              </a:lnSpc>
+              <a:buNone/>
+            </a:pPr>
+            <a:r>
+              <a:rPr lang="en-US" sz="1350" dirty="0">
+                <a:solidFill>
+                  <a:srgbClr val="14233A"/>
+                </a:solidFill>
+                <a:latin typeface="Calibri" pitchFamily="34" charset="0"/>
+                <a:ea typeface="Calibri" pitchFamily="34" charset="-122"/>
+                <a:cs typeface="Calibri" pitchFamily="34" charset="-120"/>
+              </a:rPr>
+              <a:t>you'll score ideas against criteria all semester — and the method transfers to any idea you'll ever weigh (a startup, a proposal at work).</a:t>
+            </a:r>
+            <a:endParaRPr lang="en-US" sz="1350" dirty="0"/>
+          </a:p>
+        </p:txBody>
+      </p:sp>
+      <p:sp>
+        <p:nvSpPr>
+          <p:cNvPr id="33" name="Text 23"/>
           <p:cNvSpPr/>
           <p:nvPr/>
         </p:nvSpPr>
@@ -4627,7 +4715,7 @@
       </p:sp>
       <p:sp>
         <p:nvSpPr>
-          <p:cNvPr id="32" name="Text 22"/>
+          <p:cNvPr id="34" name="Text 24"/>
           <p:cNvSpPr/>
           <p:nvPr/>
         </p:nvSpPr>

</xml_diff>